<commit_message>
Update documentation and enhance clarity for PD16 characterization
- Revised `CHARLES_CHECKLIST.md` and `README.txt` to reflect the latest sync date and clarify the transition to post-PD16 priorities.
- Updated `08_PD16_Alex_meeting_takeaways.md` to document insights from the August 6 meeting, focusing on new directions for team-level L_C and calibration.
- Enhanced various markdown files to replace references to team targets **T_j** with **T_{j*}** for consistency in the assignment process.
- Introduced new figures and CSV outputs related to the L_C distribution across different rho values, improving the diagnostic capabilities of the project.

These changes improve the organization and clarity of the documentation, ensuring users have access to the most relevant materials for the current phase of the project.
</commit_message>
<xml_diff>
--- a/3-Master_Plan/re_entry/HEROs_and_PASSes/slides/auto/CHAR_gamma_characterization_AUTO.pptx
+++ b/3-Master_Plan/re_entry/HEROs_and_PASSes/slides/auto/CHAR_gamma_characterization_AUTO.pptx
@@ -3311,7 +3311,7 @@
       </p:sp>
       <p:pic>
         <p:nvPicPr>
-          <p:cNvPr id="4" name="Picture 3" descr="GAMMA_sweep_lambda_curves.png"/>
+          <p:cNvPr id="4" name="Picture 3" descr="GAMMA_sweep_lambda_curves_key_arms.png"/>
           <p:cNvPicPr>
             <a:picLocks noChangeAspect="1"/>
           </p:cNvPicPr>
@@ -3325,8 +3325,8 @@
         </p:blipFill>
         <p:spPr>
           <a:xfrm>
-            <a:off x="4773168" y="768096"/>
-            <a:ext cx="7007047" cy="2393962"/>
+            <a:off x="6476591" y="768096"/>
+            <a:ext cx="3600201" cy="3895344"/>
           </a:xfrm>
           <a:prstGeom prst="rect">
             <a:avLst/>
@@ -3408,46 +3408,18 @@
               </a:spcAft>
             </a:pPr>
             <a:r>
+              <a:rPr sz="900"/>
+              <a:t>Figure uses key arms </a:t>
+            </a:r>
+            <a:r>
               <a:rPr sz="900" i="1">
                 <a:latin typeface="Cambria Math"/>
               </a:rPr>
-              <a:t>\gamma=5</a:t>
+              <a:t>λ ∈ {0, 0.55, 1.0}</a:t>
             </a:r>
             <a:r>
               <a:rPr sz="900"/>
-              <a:t>: </a:t>
-            </a:r>
-            <a:r>
-              <a:rPr sz="900" i="1">
-                <a:latin typeface="Cambria Math"/>
-              </a:rPr>
-              <a:t>λ</a:t>
-            </a:r>
-            <a:r>
-              <a:rPr sz="800" i="1" baseline="-25000">
-                <a:latin typeface="Cambria Math"/>
-              </a:rPr>
-              <a:t>crit</a:t>
-            </a:r>
-            <a:r>
-              <a:rPr sz="900" i="1">
-                <a:latin typeface="Cambria Math"/>
-              </a:rPr>
-              <a:t>\approx 0.8</a:t>
-            </a:r>
-            <a:r>
-              <a:rPr sz="900"/>
-              <a:t> — hump needs larger </a:t>
-            </a:r>
-            <a:r>
-              <a:rPr sz="900" i="1">
-                <a:latin typeface="Cambria Math"/>
-              </a:rPr>
-              <a:t>λ</a:t>
-            </a:r>
-            <a:r>
-              <a:rPr sz="900"/>
-              <a:t>.</a:t>
+              <a:t> — full five-arm grid in \texttt{GAMMA\_sweep\_lambda\_curves.png}.</a:t>
             </a:r>
           </a:p>
           <a:p>
@@ -3463,11 +3435,11 @@
               <a:rPr sz="900" i="1">
                 <a:latin typeface="Cambria Math"/>
               </a:rPr>
-              <a:t>\gamma=10</a:t>
+              <a:t>\gamma=5</a:t>
             </a:r>
             <a:r>
               <a:rPr sz="900"/>
-              <a:t> (539): </a:t>
+              <a:t>: </a:t>
             </a:r>
             <a:r>
               <a:rPr sz="900" i="1">
@@ -3485,17 +3457,17 @@
               <a:rPr sz="900" i="1">
                 <a:latin typeface="Cambria Math"/>
               </a:rPr>
-              <a:t>\approx 0.4</a:t>
+              <a:t>≈ 0.8</a:t>
             </a:r>
             <a:r>
               <a:rPr sz="900"/>
-              <a:t> — curve morph near </a:t>
+              <a:t> — hump needs larger </a:t>
             </a:r>
             <a:r>
               <a:rPr sz="900" i="1">
                 <a:latin typeface="Cambria Math"/>
               </a:rPr>
-              <a:t>λ \gtrsim 0.4</a:t>
+              <a:t>λ</a:t>
             </a:r>
             <a:r>
               <a:rPr sz="900"/>
@@ -3515,11 +3487,11 @@
               <a:rPr sz="900" i="1">
                 <a:latin typeface="Cambria Math"/>
               </a:rPr>
-              <a:t>\gamma=20</a:t>
+              <a:t>\gamma=10</a:t>
             </a:r>
             <a:r>
               <a:rPr sz="900"/>
-              <a:t>: </a:t>
+              <a:t> (539): </a:t>
             </a:r>
             <a:r>
               <a:rPr sz="900" i="1">
@@ -3537,17 +3509,17 @@
               <a:rPr sz="900" i="1">
                 <a:latin typeface="Cambria Math"/>
               </a:rPr>
-              <a:t>\approx 0.2</a:t>
+              <a:t>≈ 0.4</a:t>
             </a:r>
             <a:r>
               <a:rPr sz="900"/>
-              <a:t> — congestion reorders at modest </a:t>
+              <a:t> — curve morph near </a:t>
             </a:r>
             <a:r>
               <a:rPr sz="900" i="1">
                 <a:latin typeface="Cambria Math"/>
               </a:rPr>
-              <a:t>λ</a:t>
+              <a:t>λ \gtrsim 0.4</a:t>
             </a:r>
             <a:r>
               <a:rPr sz="900"/>
@@ -3661,7 +3633,7 @@
               <a:rPr sz="1100" i="1">
                 <a:latin typeface="Cambria Math"/>
               </a:rPr>
-              <a:t> \approx 4/\gamma</a:t>
+              <a:t> ≈ 4/\gamma</a:t>
             </a:r>
             <a:r>
               <a:rPr sz="1100"/>
@@ -3743,7 +3715,7 @@
               <a:rPr sz="2000" i="1">
                 <a:latin typeface="Cambria Math"/>
               </a:rPr>
-              <a:t> \approx 4/\gamma</a:t>
+              <a:t> ≈ 4/\gamma</a:t>
             </a:r>
             <a:r>
               <a:rPr sz="2000"/>
@@ -3983,7 +3955,7 @@
         <p:spPr>
           <a:xfrm>
             <a:off x="4773168" y="768096"/>
-            <a:ext cx="7007047" cy="3186656"/>
+            <a:ext cx="7007047" cy="3177248"/>
           </a:xfrm>
           <a:prstGeom prst="rect">
             <a:avLst/>
@@ -4314,7 +4286,7 @@
               <a:rPr sz="1100" i="1">
                 <a:latin typeface="Cambria Math"/>
               </a:rPr>
-              <a:t> \approx 4/\gamma</a:t>
+              <a:t> ≈ 4/\gamma</a:t>
             </a:r>
             <a:r>
               <a:rPr sz="1100"/>

</xml_diff>